<commit_message>
chore: update Epyon Road Map presentation
</commit_message>
<xml_diff>
--- a/Epyon Road Map.pptx
+++ b/Epyon Road Map.pptx
@@ -5872,14 +5872,14 @@
           <p:nvPr>
             <p:extLst>
               <p:ext uri="{D42A27DB-BD31-4B8C-83A1-F6EECF244321}">
-                <p14:modId xmlns:p14="http://schemas.microsoft.com/office/powerpoint/2010/main" val="2512994003"/>
+                <p14:modId xmlns:p14="http://schemas.microsoft.com/office/powerpoint/2010/main" val="2439494510"/>
               </p:ext>
             </p:extLst>
           </p:nvPr>
         </p:nvGraphicFramePr>
         <p:xfrm>
           <a:off x="232525" y="1190250"/>
-          <a:ext cx="8540325" cy="3642735"/>
+          <a:ext cx="8540325" cy="3677735"/>
         </p:xfrm>
         <a:graphic>
           <a:graphicData uri="http://schemas.openxmlformats.org/drawingml/2006/table">
@@ -6829,7 +6829,7 @@
                       </a:pPr>
                       <a:r>
                         <a:rPr lang="en-US" sz="1000" dirty="0"/>
-                        <a:t>Widly used as DEVSECOPS pipeline alternative</a:t>
+                        <a:t>Widly used as DEVSECOPS pipeline orchestrator</a:t>
                       </a:r>
                     </a:p>
                     <a:p>
@@ -7000,8 +7000,23 @@
                         <a:buNone/>
                       </a:pPr>
                       <a:r>
-                        <a:rPr lang="en-US" sz="1000"/>
+                        <a:rPr lang="en-US" sz="1000" dirty="0"/>
                         <a:t>STIG Checks against code bases</a:t>
+                      </a:r>
+                    </a:p>
+                    <a:p>
+                      <a:pPr marL="0" lvl="0" indent="0" algn="l" rtl="0">
+                        <a:spcBef>
+                          <a:spcPts val="0"/>
+                        </a:spcBef>
+                        <a:spcAft>
+                          <a:spcPts val="0"/>
+                        </a:spcAft>
+                        <a:buNone/>
+                      </a:pPr>
+                      <a:r>
+                        <a:rPr lang="en-US" sz="1000" dirty="0"/>
+                        <a:t>Run times will likely increase due to the complexity of checking STIG’s</a:t>
                       </a:r>
                     </a:p>
                   </a:txBody>
@@ -7051,7 +7066,7 @@
                         <a:defRPr/>
                       </a:pPr>
                       <a:r>
-                        <a:rPr lang="en-US" sz="900" b="0" i="0" u="none" strike="noStrike" cap="none">
+                        <a:rPr lang="en-US" sz="900" b="0" i="0" u="none" strike="noStrike" cap="none" dirty="0">
                           <a:solidFill>
                             <a:srgbClr val="000000"/>
                           </a:solidFill>
@@ -7085,7 +7100,7 @@
                         <a:defRPr/>
                       </a:pPr>
                       <a:r>
-                        <a:rPr lang="en-US" sz="900" b="0" i="0" u="none" strike="noStrike" cap="none">
+                        <a:rPr lang="en-US" sz="900" b="0" i="0" u="none" strike="noStrike" cap="none" dirty="0">
                           <a:solidFill>
                             <a:srgbClr val="000000"/>
                           </a:solidFill>
@@ -7119,7 +7134,7 @@
                         <a:defRPr/>
                       </a:pPr>
                       <a:r>
-                        <a:rPr lang="en-US" sz="900" b="0" i="0" u="none" strike="noStrike" cap="none">
+                        <a:rPr lang="en-US" sz="900" b="0" i="0" u="none" strike="noStrike" cap="none" dirty="0">
                           <a:solidFill>
                             <a:srgbClr val="000000"/>
                           </a:solidFill>
@@ -7187,8 +7202,8 @@
                         <a:buNone/>
                       </a:pPr>
                       <a:r>
-                        <a:rPr lang="en-US" sz="1000"/>
-                        <a:t>How to launch GITHUB actions on private repos</a:t>
+                        <a:rPr lang="en-US" sz="1000" dirty="0"/>
+                        <a:t>Launching GitHub actions to private repo’s requires additional access</a:t>
                       </a:r>
                     </a:p>
                     <a:p>
@@ -7201,7 +7216,7 @@
                         </a:spcAft>
                         <a:buNone/>
                       </a:pPr>
-                      <a:endParaRPr lang="en-US" sz="1000"/>
+                      <a:endParaRPr lang="en-US" sz="1000" dirty="0"/>
                     </a:p>
                     <a:p>
                       <a:pPr marL="0" lvl="0" indent="0" algn="l" rtl="0">
@@ -7214,10 +7229,9 @@
                         <a:buNone/>
                       </a:pPr>
                       <a:r>
-                        <a:rPr lang="en-US" sz="1000"/>
-                        <a:t>POC works locally</a:t>
+                        <a:rPr lang="en-US" sz="1000" dirty="0"/>
+                        <a:t>Proof of concept works locally</a:t>
                       </a:r>
-                      <a:endParaRPr lang="en-US" sz="1000" dirty="0"/>
                     </a:p>
                   </a:txBody>
                   <a:tcPr marL="45700" marR="45700" marT="18275" marB="18275">
@@ -7534,8 +7548,8 @@
                         <a:defRPr/>
                       </a:pPr>
                       <a:r>
-                        <a:rPr lang="en-US" sz="1000"/>
-                        <a:t>Reduce threat landscape of application</a:t>
+                        <a:rPr lang="en-US" sz="900" dirty="0"/>
+                        <a:t>Reduce threat landscape of application by assisting teams know what STIG’s need to be applied</a:t>
                       </a:r>
                     </a:p>
                   </a:txBody>
@@ -8383,6 +8397,10 @@
                         </a:spcAft>
                         <a:buNone/>
                       </a:pPr>
+                      <a:r>
+                        <a:rPr lang="en-US" sz="800" dirty="0"/>
+                        <a:t>Integration of MIDAS to provide code remediations</a:t>
+                      </a:r>
                       <a:endParaRPr sz="800" dirty="0"/>
                     </a:p>
                   </a:txBody>

</xml_diff>